<commit_message>
Tira o travessão dos slides, seguindo o estilo do deck de origem
O deck do Fiuza usa zero travessao em 1884 palavras: ele separa termo de
definicao com dois-pontos. Os nossos slides tinham 105, sendo 53 so na
Aula 1. Convertidos os 86 casos 'termo - definicao' e reescritos os 19 do
meio da frase.

Claude-Session: https://claude.ai/code/session_016GMgpXPXmiU667CemqAQe2
</commit_message>
<xml_diff>
--- a/slides/build/aula-01-fundamentos-de-back-end.pptx
+++ b/slides/build/aula-01-fundamentos-de-back-end.pptx
@@ -6899,7 +6899,7 @@
                 <a:cs typeface="Open Sans Extra Bold"/>
                 <a:sym typeface="Open Sans Extra Bold"/>
               </a:rPr>
-              <a:t>Nada disso pode viver no front — o usuário mexeria.</a:t>
+              <a:t>Nada disso pode viver no front. O usuário mexeria.</a:t>
             </a:r>
           </a:p>
         </p:txBody>
@@ -7712,7 +7712,7 @@
                 <a:cs typeface="Open Sans Extra Bold"/>
                 <a:sym typeface="Open Sans Extra Bold"/>
               </a:rPr>
-              <a:t>Na sua máquina ou numa VM na nuvem — é o mesmo programa.</a:t>
+              <a:t>Na sua máquina ou numa VM na nuvem, é o mesmo programa.</a:t>
             </a:r>
           </a:p>
         </p:txBody>
@@ -8268,7 +8268,7 @@
                 <a:cs typeface="Open Sans Extra Bold"/>
                 <a:sym typeface="Open Sans Extra Bold"/>
               </a:rPr>
-              <a:t>A resposta fica em cache por um tempo — o TTL.</a:t>
+              <a:t>A resposta fica em cache por um tempo. Chama-se TTL.</a:t>
             </a:r>
           </a:p>
           <a:p>
@@ -9747,7 +9747,7 @@
                 <a:cs typeface="Open Sans Extra Bold"/>
                 <a:sym typeface="Open Sans Extra Bold"/>
               </a:rPr>
-              <a:t>Content-Type — em que formato vai o corpo</a:t>
+              <a:t>Content-Type: em que formato vai o corpo</a:t>
             </a:r>
           </a:p>
           <a:p>
@@ -9768,7 +9768,7 @@
                 <a:cs typeface="Open Sans Extra Bold"/>
                 <a:sym typeface="Open Sans Extra Bold"/>
               </a:rPr>
-              <a:t>Accept — em que formato eu quero a resposta</a:t>
+              <a:t>Accept: em que formato eu quero a resposta</a:t>
             </a:r>
           </a:p>
           <a:p>
@@ -9789,7 +9789,7 @@
                 <a:cs typeface="Open Sans Extra Bold"/>
                 <a:sym typeface="Open Sans Extra Bold"/>
               </a:rPr>
-              <a:t>Authorization — quem sou eu (vai ser o nosso token, na Aula 3)</a:t>
+              <a:t>Authorization: quem sou eu (vai ser o nosso token, na Aula 3)</a:t>
             </a:r>
           </a:p>
           <a:p>
@@ -9810,7 +9810,7 @@
                 <a:cs typeface="Open Sans Extra Bold"/>
                 <a:sym typeface="Open Sans Extra Bold"/>
               </a:rPr>
-              <a:t>Set-Cookie / Cookie — como o navegador guarda estado</a:t>
+              <a:t>Set-Cookie / Cookie: como o navegador guarda estado</a:t>
             </a:r>
           </a:p>
           <a:p>
@@ -9831,7 +9831,7 @@
                 <a:cs typeface="Open Sans Extra Bold"/>
                 <a:sym typeface="Open Sans Extra Bold"/>
               </a:rPr>
-              <a:t>User-Agent — que programa está chamando</a:t>
+              <a:t>User-Agent: que programa está chamando</a:t>
             </a:r>
           </a:p>
         </p:txBody>
@@ -10324,7 +10324,7 @@
                 <a:cs typeface="Open Sans Extra Bold"/>
                 <a:sym typeface="Open Sans Extra Bold"/>
               </a:rPr>
-              <a:t>GET — me dá isso (não muda nada)</a:t>
+              <a:t>GET: me dá isso (não muda nada)</a:t>
             </a:r>
           </a:p>
           <a:p>
@@ -10345,7 +10345,7 @@
                 <a:cs typeface="Open Sans Extra Bold"/>
                 <a:sym typeface="Open Sans Extra Bold"/>
               </a:rPr>
-              <a:t>POST — cria isso</a:t>
+              <a:t>POST: cria isso</a:t>
             </a:r>
           </a:p>
           <a:p>
@@ -10366,7 +10366,7 @@
                 <a:cs typeface="Open Sans Extra Bold"/>
                 <a:sym typeface="Open Sans Extra Bold"/>
               </a:rPr>
-              <a:t>PUT / PATCH — altera isso</a:t>
+              <a:t>PUT / PATCH: altera isso</a:t>
             </a:r>
           </a:p>
           <a:p>
@@ -10387,7 +10387,7 @@
                 <a:cs typeface="Open Sans Extra Bold"/>
                 <a:sym typeface="Open Sans Extra Bold"/>
               </a:rPr>
-              <a:t>DELETE — apaga isso</a:t>
+              <a:t>DELETE: apaga isso</a:t>
             </a:r>
           </a:p>
           <a:p>
@@ -10602,7 +10602,7 @@
                 <a:cs typeface="Open Sans Extra Bold"/>
                 <a:sym typeface="Open Sans Extra Bold"/>
               </a:rPr>
-              <a:t>2xx — deu certo. 200 ok, 201 criado.</a:t>
+              <a:t>2xx: deu certo. 200 ok, 201 criado.</a:t>
             </a:r>
           </a:p>
           <a:p>
@@ -10623,7 +10623,7 @@
                 <a:cs typeface="Open Sans Extra Bold"/>
                 <a:sym typeface="Open Sans Extra Bold"/>
               </a:rPr>
-              <a:t>3xx — foi pra outro lugar.</a:t>
+              <a:t>3xx: foi pra outro lugar.</a:t>
             </a:r>
           </a:p>
           <a:p>
@@ -10644,7 +10644,7 @@
                 <a:cs typeface="Open Sans Extra Bold"/>
                 <a:sym typeface="Open Sans Extra Bold"/>
               </a:rPr>
-              <a:t>4xx — você errou. 400 pedido mal feito, 401 não autenticado,</a:t>
+              <a:t>4xx: você errou. 400 pedido mal feito, 401 não autenticado,</a:t>
             </a:r>
           </a:p>
           <a:p>
@@ -10686,7 +10686,7 @@
                 <a:cs typeface="Open Sans Extra Bold"/>
                 <a:sym typeface="Open Sans Extra Bold"/>
               </a:rPr>
-              <a:t>5xx — nós erramos. 500 é bug nosso.</a:t>
+              <a:t>5xx: nós erramos. 500 é bug nosso.</a:t>
             </a:r>
           </a:p>
           <a:p>
@@ -12547,7 +12547,7 @@
                 <a:cs typeface="Open Sans Extra Bold"/>
                 <a:sym typeface="Open Sans Extra Bold"/>
               </a:rPr>
-              <a:t>Interpretada, dinâmica, orientada a objetos — como Python.</a:t>
+              <a:t>Interpretada, dinâmica e orientada a objetos, como Python.</a:t>
             </a:r>
           </a:p>
           <a:p>
@@ -14091,7 +14091,7 @@
                 <a:cs typeface="Open Sans Extra Bold"/>
                 <a:sym typeface="Open Sans Extra Bold"/>
               </a:rPr>
-              <a:t>Não existe em Python — lá você usaria uma string.</a:t>
+              <a:t>Não existe em Python: lá você usaria uma string.</a:t>
             </a:r>
           </a:p>
           <a:p>
@@ -19180,7 +19180,7 @@
                 <a:cs typeface="Open Sans Extra Bold"/>
                 <a:sym typeface="Open Sans Extra Bold"/>
               </a:rPr>
-              <a:t>Ruby LSP — autocomplete e erro em tempo real</a:t>
+              <a:t>Ruby LSP: autocomplete e erro em tempo real</a:t>
             </a:r>
           </a:p>
           <a:p>
@@ -19201,7 +19201,7 @@
                 <a:cs typeface="Open Sans Extra Bold"/>
                 <a:sym typeface="Open Sans Extra Bold"/>
               </a:rPr>
-              <a:t>Ruby Rails — pula entre model, controller e rota</a:t>
+              <a:t>Ruby Rails: pula entre model, controller e rota</a:t>
             </a:r>
           </a:p>
           <a:p>
@@ -19222,7 +19222,7 @@
                 <a:cs typeface="Open Sans Extra Bold"/>
                 <a:sym typeface="Open Sans Extra Bold"/>
               </a:rPr>
-              <a:t>Docker — ver e parar containers pela barra lateral</a:t>
+              <a:t>Docker: ver e parar containers pela barra lateral</a:t>
             </a:r>
           </a:p>
           <a:p>
@@ -19243,7 +19243,7 @@
                 <a:cs typeface="Open Sans Extra Bold"/>
                 <a:sym typeface="Open Sans Extra Bold"/>
               </a:rPr>
-              <a:t>GitLens — quem escreveu esta linha, e quando</a:t>
+              <a:t>GitLens: quem escreveu esta linha, e quando</a:t>
             </a:r>
           </a:p>
           <a:p>
@@ -19264,7 +19264,7 @@
                 <a:cs typeface="Open Sans Extra Bold"/>
                 <a:sym typeface="Open Sans Extra Bold"/>
               </a:rPr>
-              <a:t>WSL — só Windows, abre o projeto do Ubuntu</a:t>
+              <a:t>WSL: só Windows, abre o projeto do Ubuntu</a:t>
             </a:r>
           </a:p>
           <a:p>
@@ -19500,7 +19500,7 @@
                 <a:cs typeface="Open Sans Extra Bold"/>
                 <a:sym typeface="Open Sans Extra Bold"/>
               </a:rPr>
-              <a:t>Nasceu extraído do Basecamp — um produto real, não um exercício.</a:t>
+              <a:t>Nasceu extraído do Basecamp: um produto real, não um exercício.</a:t>
             </a:r>
           </a:p>
           <a:p>
@@ -20842,7 +20842,7 @@
                 <a:cs typeface="Open Sans Extra Bold"/>
                 <a:sym typeface="Open Sans Extra Bold"/>
               </a:rPr>
-              <a:t>Model — os dados e as regras. Conversa com o banco.</a:t>
+              <a:t>Model: os dados e as regras. Conversa com o banco.</a:t>
             </a:r>
           </a:p>
           <a:p>
@@ -20863,7 +20863,7 @@
                 <a:cs typeface="Open Sans Extra Bold"/>
                 <a:sym typeface="Open Sans Extra Bold"/>
               </a:rPr>
-              <a:t>View — a tela. Na nossa API, é o JSON.</a:t>
+              <a:t>View: a tela. Na nossa API, é o JSON.</a:t>
             </a:r>
           </a:p>
           <a:p>
@@ -20884,7 +20884,7 @@
                 <a:cs typeface="Open Sans Extra Bold"/>
                 <a:sym typeface="Open Sans Extra Bold"/>
               </a:rPr>
-              <a:t>Controller — recebe a requisição e decide o que fazer.</a:t>
+              <a:t>Controller: recebe a requisição e decide o que fazer.</a:t>
             </a:r>
           </a:p>
           <a:p>
@@ -20905,7 +20905,7 @@
                 <a:cs typeface="Open Sans Extra Bold"/>
                 <a:sym typeface="Open Sans Extra Bold"/>
               </a:rPr>
-              <a:t>Rota — o mapa: este endereço vai para aquele controller.</a:t>
+              <a:t>Rota: o mapa que liga este endereço àquele controller.</a:t>
             </a:r>
           </a:p>
           <a:p>
@@ -21504,7 +21504,7 @@
                 <a:cs typeface="Open Sans Extra Bold"/>
                 <a:sym typeface="Open Sans Extra Bold"/>
               </a:rPr>
-              <a:t>Errou o caminho, a classe não existe. Não é estilo — é mecanismo.</a:t>
+              <a:t>Errou o caminho, a classe não existe. Não é estilo. É mecanismo.</a:t>
             </a:r>
           </a:p>
           <a:p>
@@ -21719,7 +21719,7 @@
                 <a:cs typeface="Open Sans Extra Bold"/>
                 <a:sym typeface="Open Sans Extra Bold"/>
               </a:rPr>
-              <a:t>development — sua máquina. Recarrega código, log verboso, erro na tela.</a:t>
+              <a:t>development: sua máquina. Recarrega código, log verboso, erro na tela.</a:t>
             </a:r>
           </a:p>
           <a:p>
@@ -21740,7 +21740,7 @@
                 <a:cs typeface="Open Sans Extra Bold"/>
                 <a:sym typeface="Open Sans Extra Bold"/>
               </a:rPr>
-              <a:t>test — os testes. Banco separado, que é limpo a cada teste.</a:t>
+              <a:t>test: os testes. Banco separado, que é limpo a cada teste.</a:t>
             </a:r>
           </a:p>
           <a:p>
@@ -21761,7 +21761,7 @@
                 <a:cs typeface="Open Sans Extra Bold"/>
                 <a:sym typeface="Open Sans Extra Bold"/>
               </a:rPr>
-              <a:t>production — o servidor. Código congelado, log enxuto, erro genérico.</a:t>
+              <a:t>production: o servidor. Código congelado, log enxuto, erro genérico.</a:t>
             </a:r>
           </a:p>
           <a:p>
@@ -22018,7 +22018,7 @@
                 <a:cs typeface="Open Sans Extra Bold"/>
                 <a:sym typeface="Open Sans Extra Bold"/>
               </a:rPr>
-              <a:t>app/ — o seu código. É onde você passa 90% do tempo.</a:t>
+              <a:t>app/: o seu código. É onde você passa 90% do tempo.</a:t>
             </a:r>
           </a:p>
           <a:p>
@@ -22060,7 +22060,7 @@
                 <a:cs typeface="Open Sans Extra Bold"/>
                 <a:sym typeface="Open Sans Extra Bold"/>
               </a:rPr>
-              <a:t>config/ — rotas, banco, ambientes, credenciais</a:t>
+              <a:t>config/: rotas, banco, ambientes, credenciais</a:t>
             </a:r>
           </a:p>
           <a:p>
@@ -22081,7 +22081,7 @@
                 <a:cs typeface="Open Sans Extra Bold"/>
                 <a:sym typeface="Open Sans Extra Bold"/>
               </a:rPr>
-              <a:t>db/ — migrations e o retrato atual do banco (schema.rb)</a:t>
+              <a:t>db/: migrations e o retrato atual do banco (schema.rb)</a:t>
             </a:r>
           </a:p>
           <a:p>
@@ -22102,7 +22102,7 @@
                 <a:cs typeface="Open Sans Extra Bold"/>
                 <a:sym typeface="Open Sans Extra Bold"/>
               </a:rPr>
-              <a:t>test/ — os testes</a:t>
+              <a:t>test/: os testes</a:t>
             </a:r>
           </a:p>
           <a:p>
@@ -22123,7 +22123,7 @@
                 <a:cs typeface="Open Sans Extra Bold"/>
                 <a:sym typeface="Open Sans Extra Bold"/>
               </a:rPr>
-              <a:t>Gemfile — as dependências</a:t>
+              <a:t>Gemfile: as dependências</a:t>
             </a:r>
           </a:p>
           <a:p>
@@ -22144,7 +22144,7 @@
                 <a:cs typeface="Open Sans Extra Bold"/>
                 <a:sym typeface="Open Sans Extra Bold"/>
               </a:rPr>
-              <a:t>bin/ — os comandos: rails, setup, dev</a:t>
+              <a:t>bin/ tem os comandos: rails, setup, dev</a:t>
             </a:r>
           </a:p>
         </p:txBody>
@@ -22338,7 +22338,7 @@
                 <a:cs typeface="Open Sans Extra Bold"/>
                 <a:sym typeface="Open Sans Extra Bold"/>
               </a:rPr>
-              <a:t>bin/rails server — sobe a aplicação</a:t>
+              <a:t>bin/rails server: sobe a aplicação</a:t>
             </a:r>
           </a:p>
           <a:p>
@@ -22359,7 +22359,7 @@
                 <a:cs typeface="Open Sans Extra Bold"/>
                 <a:sym typeface="Open Sans Extra Bold"/>
               </a:rPr>
-              <a:t>bin/rails console — um irb com o seu projeto carregado dentro</a:t>
+              <a:t>bin/rails console: um irb com o seu projeto carregado dentro</a:t>
             </a:r>
           </a:p>
           <a:p>
@@ -22380,7 +22380,7 @@
                 <a:cs typeface="Open Sans Extra Bold"/>
                 <a:sym typeface="Open Sans Extra Bold"/>
               </a:rPr>
-              <a:t>bin/rails routes — todas as rotas que existem</a:t>
+              <a:t>bin/rails routes: todas as rotas que existem</a:t>
             </a:r>
           </a:p>
           <a:p>
@@ -22401,7 +22401,7 @@
                 <a:cs typeface="Open Sans Extra Bold"/>
                 <a:sym typeface="Open Sans Extra Bold"/>
               </a:rPr>
-              <a:t>bin/rails generate — cria arquivos seguindo a convenção</a:t>
+              <a:t>bin/rails generate: cria arquivos seguindo a convenção</a:t>
             </a:r>
           </a:p>
           <a:p>
@@ -22422,7 +22422,7 @@
                 <a:cs typeface="Open Sans Extra Bold"/>
                 <a:sym typeface="Open Sans Extra Bold"/>
               </a:rPr>
-              <a:t>bin/rails db:migrate — aplica as mudanças de banco</a:t>
+              <a:t>bin/rails db:migrate aplica as mudanças de banco</a:t>
             </a:r>
           </a:p>
           <a:p>
@@ -22443,7 +22443,7 @@
                 <a:cs typeface="Open Sans Extra Bold"/>
                 <a:sym typeface="Open Sans Extra Bold"/>
               </a:rPr>
-              <a:t>bin/rails test — roda os testes</a:t>
+              <a:t>bin/rails test: roda os testes</a:t>
             </a:r>
           </a:p>
         </p:txBody>
@@ -22658,7 +22658,7 @@
                 <a:cs typeface="Open Sans Extra Bold"/>
                 <a:sym typeface="Open Sans Extra Bold"/>
               </a:rPr>
-              <a:t>pwd — onde eu estou</a:t>
+              <a:t>pwd: onde eu estou</a:t>
             </a:r>
           </a:p>
           <a:p>
@@ -22679,7 +22679,7 @@
                 <a:cs typeface="Open Sans Extra Bold"/>
                 <a:sym typeface="Open Sans Extra Bold"/>
               </a:rPr>
-              <a:t>ls — o que tem aqui</a:t>
+              <a:t>ls: o que tem aqui</a:t>
             </a:r>
           </a:p>
           <a:p>
@@ -22700,7 +22700,7 @@
                 <a:cs typeface="Open Sans Extra Bold"/>
                 <a:sym typeface="Open Sans Extra Bold"/>
               </a:rPr>
-              <a:t>cd pasta — entrar</a:t>
+              <a:t>cd pasta: entrar</a:t>
             </a:r>
           </a:p>
           <a:p>
@@ -22721,7 +22721,7 @@
                 <a:cs typeface="Open Sans Extra Bold"/>
                 <a:sym typeface="Open Sans Extra Bold"/>
               </a:rPr>
-              <a:t>cd .. — voltar</a:t>
+              <a:t>cd ..: voltar</a:t>
             </a:r>
           </a:p>
           <a:p>
@@ -23684,7 +23684,7 @@
                 <a:cs typeface="Open Sans Extra Bold"/>
                 <a:sym typeface="Open Sans Extra Bold"/>
               </a:rPr>
-              <a:t>git init — começa a versionar</a:t>
+              <a:t>git init: começa a versionar</a:t>
             </a:r>
           </a:p>
           <a:p>
@@ -23705,7 +23705,7 @@
                 <a:cs typeface="Open Sans Extra Bold"/>
                 <a:sym typeface="Open Sans Extra Bold"/>
               </a:rPr>
-              <a:t>git add . — separa o que vai no próximo commit</a:t>
+              <a:t>git add .: separa o que vai no próximo commit</a:t>
             </a:r>
           </a:p>
           <a:p>
@@ -23726,7 +23726,7 @@
                 <a:cs typeface="Open Sans Extra Bold"/>
                 <a:sym typeface="Open Sans Extra Bold"/>
               </a:rPr>
-              <a:t>git commit -m "mensagem" — grava o ponto</a:t>
+              <a:t>git commit -m "mensagem": grava o ponto</a:t>
             </a:r>
           </a:p>
           <a:p>
@@ -23747,7 +23747,7 @@
                 <a:cs typeface="Open Sans Extra Bold"/>
                 <a:sym typeface="Open Sans Extra Bold"/>
               </a:rPr>
-              <a:t>git push — manda para o GitHub</a:t>
+              <a:t>git push: manda para o GitHub</a:t>
             </a:r>
           </a:p>
           <a:p>
@@ -24025,7 +24025,7 @@
                 <a:cs typeface="Open Sans Extra Bold"/>
                 <a:sym typeface="Open Sans Extra Bold"/>
               </a:rPr>
-              <a:t>Rails decide o óbvio por você — siga a convenção.</a:t>
+              <a:t>Rails decide o óbvio por você. Siga a convenção.</a:t>
             </a:r>
           </a:p>
           <a:p>

</xml_diff>

<commit_message>
Deixa explícito que o aluno trabalha no projeto dele, não neste repo
O modelo estava incoerente: a Aula 1 mandava criar projeto proprio, a Aula 3
mandava dar checkout neste repositorio, e a Aula 4 exige um repo do proprio
aluno no GitHub (o OIDC e emitido para repo:SEU-USUARIO/SEU-REPO).

Fica: o aluno cria e publica o projeto dele na Aula 1; este repositorio e
gabarito de leitura. O exercicio da Aula 1 virou passo a passo executavel,
com todo o codigo, e foi testado partindo de um rails new limpo. O rsync do
gabarito precisava do Gemfile junto (jwt, rack-cors, letter_opener) para o
app subir.

Claude-Session: https://claude.ai/code/session_016GMgpXPXmiU667CemqAQe2
</commit_message>
<xml_diff>
--- a/slides/build/aula-01-fundamentos-de-back-end.pptx
+++ b/slides/build/aula-01-fundamentos-de-back-end.pptx
@@ -69,6 +69,7 @@
     <p:sldId id="317" r:id="rId71"/>
     <p:sldId id="318" r:id="rId72"/>
     <p:sldId id="319" r:id="rId73"/>
+    <p:sldId id="320" r:id="rId74"/>
   </p:sldIdLst>
   <p:sldSz cx="18288000" cy="10287000"/>
   <p:notesSz cx="6858000" cy="9144000"/>
@@ -2019,12 +2020,23 @@
           <a:lstStyle/>
           <a:p>
             <a:r>
-              <a:t>Esta é a entrega da aula. Ninguém sai daqui sem os 200 na tela.</a:t>
-            </a:r>
-          </a:p>
-          <a:p>
-            <a:r>
-              <a:t>Quem travar: git checkout aula-01.</a:t>
+              <a:t>Esta é a entrega da aula. Ninguém sai daqui sem os 200 na tela E sem o</a:t>
+            </a:r>
+          </a:p>
+          <a:p>
+            <a:r>
+              <a:t>projeto no GitHub deles — a Aula 4 depende disso.</a:t>
+            </a:r>
+          </a:p>
+          <a:p/>
+          <a:p>
+            <a:r>
+              <a:t>Os passos 1 a 7 estão com todo o código na apostila, seção "Exercício da</a:t>
+            </a:r>
+          </a:p>
+          <a:p>
+            <a:r>
+              <a:t>aula". Mande abrir. Quem travar, projete o gabarito e deixe digitar.</a:t>
             </a:r>
           </a:p>
         </p:txBody>
@@ -23335,14 +23347,14 @@
             <a:r>
               <a:rPr lang="en-US" sz="4242">
                 <a:solidFill>
-                  <a:srgbClr val="48B1FF"/>
-                </a:solidFill>
-                <a:latin typeface="Open Sans Extra Bold"/>
-                <a:ea typeface="Open Sans Extra Bold"/>
-                <a:cs typeface="Open Sans Extra Bold"/>
-                <a:sym typeface="Open Sans Extra Bold"/>
-              </a:rPr>
-              <a:t>PRÁTICA</a:t>
+                  <a:srgbClr val="FF751F"/>
+                </a:solidFill>
+                <a:latin typeface="Open Sans Extra Bold"/>
+                <a:ea typeface="Open Sans Extra Bold"/>
+                <a:cs typeface="Open Sans Extra Bold"/>
+                <a:sym typeface="Open Sans Extra Bold"/>
+              </a:rPr>
+              <a:t>DOIS DIRETÓRIOS</a:t>
             </a:r>
           </a:p>
         </p:txBody>
@@ -23385,7 +23397,7 @@
                 <a:cs typeface="Open Sans Extra Bold"/>
                 <a:sym typeface="Open Sans Extra Bold"/>
               </a:rPr>
-              <a:t>Crie o projeto com rails new.</a:t>
+              <a:t>~/capacitacao-gabarito é o repositório da capacitação. Só leitura.</a:t>
             </a:r>
           </a:p>
           <a:p>
@@ -23406,7 +23418,7 @@
                 <a:cs typeface="Open Sans Extra Bold"/>
                 <a:sym typeface="Open Sans Extra Bold"/>
               </a:rPr>
-              <a:t>Suba o Postgres com docker compose up -d.</a:t>
+              <a:t>~/automic_auth_api é o SEU projeto. É nele que você escreve.</a:t>
             </a:r>
           </a:p>
           <a:p>
@@ -23427,7 +23439,7 @@
                 <a:cs typeface="Open Sans Extra Bold"/>
                 <a:sym typeface="Open Sans Extra Bold"/>
               </a:rPr>
-              <a:t>Rode bin/rails server e abra http://localhost:3000/up.</a:t>
+              <a:t>Travou? Abra o mesmo arquivo no gabarito, entenda, e digite no seu.</a:t>
             </a:r>
           </a:p>
           <a:p>
@@ -23448,7 +23460,7 @@
                 <a:cs typeface="Open Sans Extra Bold"/>
                 <a:sym typeface="Open Sans Extra Bold"/>
               </a:rPr>
-              <a:t>Crie a rota GET /api/v1/status.</a:t>
+              <a:t>O seu projeto vai para o SEU GitHub, hoje ainda.</a:t>
             </a:r>
           </a:p>
           <a:p>
@@ -23469,7 +23481,7 @@
                 <a:cs typeface="Open Sans Extra Bold"/>
                 <a:sym typeface="Open Sans Extra Bold"/>
               </a:rPr>
-              <a:t>Chame ela no Insomnia e confira o status 200.</a:t>
+              <a:t>Na Aula 4 o deploy é autorizado para repo:SEU-USUARIO/SEU-REPO.</a:t>
             </a:r>
           </a:p>
           <a:p>
@@ -23490,7 +23502,7 @@
                 <a:cs typeface="Open Sans Extra Bold"/>
                 <a:sym typeface="Open Sans Extra Bold"/>
               </a:rPr>
-              <a:t>Rode bin/rails routes e ache a sua rota na lista.</a:t>
+              <a:t>Não dá para apontar para o meu repositório.</a:t>
             </a:r>
           </a:p>
         </p:txBody>
@@ -23634,14 +23646,14 @@
             <a:r>
               <a:rPr lang="en-US" sz="4242">
                 <a:solidFill>
-                  <a:srgbClr val="FF751F"/>
-                </a:solidFill>
-                <a:latin typeface="Open Sans Extra Bold"/>
-                <a:ea typeface="Open Sans Extra Bold"/>
-                <a:cs typeface="Open Sans Extra Bold"/>
-                <a:sym typeface="Open Sans Extra Bold"/>
-              </a:rPr>
-              <a:t>GIT</a:t>
+                  <a:srgbClr val="48B1FF"/>
+                </a:solidFill>
+                <a:latin typeface="Open Sans Extra Bold"/>
+                <a:ea typeface="Open Sans Extra Bold"/>
+                <a:cs typeface="Open Sans Extra Bold"/>
+                <a:sym typeface="Open Sans Extra Bold"/>
+              </a:rPr>
+              <a:t>PRÁTICA</a:t>
             </a:r>
           </a:p>
         </p:txBody>
@@ -23669,13 +23681,13 @@
           <a:p>
             <a:pPr algn="l" marL="1136378" indent="-568189" lvl="1">
               <a:lnSpc>
-                <a:spcPts val="6236"/>
+                <a:spcPts val="4989"/>
               </a:lnSpc>
               <a:buFont typeface="Arial"/>
               <a:buChar char="•"/>
             </a:pPr>
             <a:r>
-              <a:rPr lang="en-US" sz="3947">
+              <a:rPr lang="en-US" sz="3157">
                 <a:solidFill>
                   <a:srgbClr val="000000"/>
                 </a:solidFill>
@@ -23684,19 +23696,19 @@
                 <a:cs typeface="Open Sans Extra Bold"/>
                 <a:sym typeface="Open Sans Extra Bold"/>
               </a:rPr>
-              <a:t>git init: começa a versionar</a:t>
+              <a:t>Crie o projeto: rails new --api -d postgresql</a:t>
             </a:r>
           </a:p>
           <a:p>
             <a:pPr algn="l" marL="1136378" indent="-568189" lvl="1">
               <a:lnSpc>
-                <a:spcPts val="6236"/>
+                <a:spcPts val="4989"/>
               </a:lnSpc>
               <a:buFont typeface="Arial"/>
               <a:buChar char="•"/>
             </a:pPr>
             <a:r>
-              <a:rPr lang="en-US" sz="3947">
+              <a:rPr lang="en-US" sz="3157">
                 <a:solidFill>
                   <a:srgbClr val="000000"/>
                 </a:solidFill>
@@ -23705,19 +23717,19 @@
                 <a:cs typeface="Open Sans Extra Bold"/>
                 <a:sym typeface="Open Sans Extra Bold"/>
               </a:rPr>
-              <a:t>git add .: separa o que vai no próximo commit</a:t>
+              <a:t>Publique no seu GitHub: gh repo create --source=. --push</a:t>
             </a:r>
           </a:p>
           <a:p>
             <a:pPr algn="l" marL="1136378" indent="-568189" lvl="1">
               <a:lnSpc>
-                <a:spcPts val="6236"/>
+                <a:spcPts val="4989"/>
               </a:lnSpc>
               <a:buFont typeface="Arial"/>
               <a:buChar char="•"/>
             </a:pPr>
             <a:r>
-              <a:rPr lang="en-US" sz="3947">
+              <a:rPr lang="en-US" sz="3157">
                 <a:solidFill>
                   <a:srgbClr val="000000"/>
                 </a:solidFill>
@@ -23726,19 +23738,19 @@
                 <a:cs typeface="Open Sans Extra Bold"/>
                 <a:sym typeface="Open Sans Extra Bold"/>
               </a:rPr>
-              <a:t>git commit -m "mensagem": grava o ponto</a:t>
+              <a:t>Suba o banco e a aplicação. Abra /up.</a:t>
             </a:r>
           </a:p>
           <a:p>
             <a:pPr algn="l" marL="1136378" indent="-568189" lvl="1">
               <a:lnSpc>
-                <a:spcPts val="6236"/>
+                <a:spcPts val="4989"/>
               </a:lnSpc>
               <a:buFont typeface="Arial"/>
               <a:buChar char="•"/>
             </a:pPr>
             <a:r>
-              <a:rPr lang="en-US" sz="3947">
+              <a:rPr lang="en-US" sz="3157">
                 <a:solidFill>
                   <a:srgbClr val="000000"/>
                 </a:solidFill>
@@ -23747,19 +23759,19 @@
                 <a:cs typeface="Open Sans Extra Bold"/>
                 <a:sym typeface="Open Sans Extra Bold"/>
               </a:rPr>
-              <a:t>git push: manda para o GitHub</a:t>
+              <a:t>Escreva a rota GET /api/v1/status e o teste dela.</a:t>
             </a:r>
           </a:p>
           <a:p>
             <a:pPr algn="l" marL="1136378" indent="-568189" lvl="1">
               <a:lnSpc>
-                <a:spcPts val="6236"/>
+                <a:spcPts val="4989"/>
               </a:lnSpc>
               <a:buFont typeface="Arial"/>
               <a:buChar char="•"/>
             </a:pPr>
             <a:r>
-              <a:rPr lang="en-US" sz="3947">
+              <a:rPr lang="en-US" sz="3157">
                 <a:solidFill>
                   <a:srgbClr val="000000"/>
                 </a:solidFill>
@@ -23768,7 +23780,28 @@
                 <a:cs typeface="Open Sans Extra Bold"/>
                 <a:sym typeface="Open Sans Extra Bold"/>
               </a:rPr>
-              <a:t>Na Aula 4, é o push que dispara o deploy. Literalmente.</a:t>
+              <a:t>Confira no Insomnia: 200.</a:t>
+            </a:r>
+          </a:p>
+          <a:p>
+            <a:pPr algn="l" marL="1136378" indent="-568189" lvl="1">
+              <a:lnSpc>
+                <a:spcPts val="4989"/>
+              </a:lnSpc>
+              <a:buFont typeface="Arial"/>
+              <a:buChar char="•"/>
+            </a:pPr>
+            <a:r>
+              <a:rPr lang="en-US" sz="3157">
+                <a:solidFill>
+                  <a:srgbClr val="000000"/>
+                </a:solidFill>
+                <a:latin typeface="Open Sans Extra Bold"/>
+                <a:ea typeface="Open Sans Extra Bold"/>
+                <a:cs typeface="Open Sans Extra Bold"/>
+                <a:sym typeface="Open Sans Extra Bold"/>
+              </a:rPr>
+              <a:t>Todos os comandos estão na apostila, em Exercício da aula.</a:t>
             </a:r>
           </a:p>
         </p:txBody>
@@ -23919,7 +23952,7 @@
                 <a:cs typeface="Open Sans Extra Bold"/>
                 <a:sym typeface="Open Sans Extra Bold"/>
               </a:rPr>
-              <a:t>RECAPITULANDO</a:t>
+              <a:t>GIT</a:t>
             </a:r>
           </a:p>
         </p:txBody>
@@ -23947,13 +23980,13 @@
           <a:p>
             <a:pPr algn="l" marL="1136378" indent="-568189" lvl="1">
               <a:lnSpc>
-                <a:spcPts val="5821"/>
+                <a:spcPts val="6236"/>
               </a:lnSpc>
               <a:buFont typeface="Arial"/>
               <a:buChar char="•"/>
             </a:pPr>
             <a:r>
-              <a:rPr lang="en-US" sz="3684">
+              <a:rPr lang="en-US" sz="3947">
                 <a:solidFill>
                   <a:srgbClr val="000000"/>
                 </a:solidFill>
@@ -23962,19 +23995,19 @@
                 <a:cs typeface="Open Sans Extra Bold"/>
                 <a:sym typeface="Open Sans Extra Bold"/>
               </a:rPr>
-              <a:t>Back-end é a cozinha: regra, dado e permissão.</a:t>
+              <a:t>git init: começa a versionar</a:t>
             </a:r>
           </a:p>
           <a:p>
             <a:pPr algn="l" marL="1136378" indent="-568189" lvl="1">
               <a:lnSpc>
-                <a:spcPts val="5821"/>
+                <a:spcPts val="6236"/>
               </a:lnSpc>
               <a:buFont typeface="Arial"/>
               <a:buChar char="•"/>
             </a:pPr>
             <a:r>
-              <a:rPr lang="en-US" sz="3684">
+              <a:rPr lang="en-US" sz="3947">
                 <a:solidFill>
                   <a:srgbClr val="000000"/>
                 </a:solidFill>
@@ -23983,19 +24016,19 @@
                 <a:cs typeface="Open Sans Extra Bold"/>
                 <a:sym typeface="Open Sans Extra Bold"/>
               </a:rPr>
-              <a:t>HTTP é o idioma; verbo, status e JSON são o vocabulário.</a:t>
+              <a:t>git add .: separa o que vai no próximo commit</a:t>
             </a:r>
           </a:p>
           <a:p>
             <a:pPr algn="l" marL="1136378" indent="-568189" lvl="1">
               <a:lnSpc>
-                <a:spcPts val="5821"/>
+                <a:spcPts val="6236"/>
               </a:lnSpc>
               <a:buFont typeface="Arial"/>
               <a:buChar char="•"/>
             </a:pPr>
             <a:r>
-              <a:rPr lang="en-US" sz="3684">
+              <a:rPr lang="en-US" sz="3947">
                 <a:solidFill>
                   <a:srgbClr val="000000"/>
                 </a:solidFill>
@@ -24004,19 +24037,19 @@
                 <a:cs typeface="Open Sans Extra Bold"/>
                 <a:sym typeface="Open Sans Extra Bold"/>
               </a:rPr>
-              <a:t>Ruby é Python com outra sintaxe e mais açúcar.</a:t>
+              <a:t>git commit -m "mensagem": grava o ponto</a:t>
             </a:r>
           </a:p>
           <a:p>
             <a:pPr algn="l" marL="1136378" indent="-568189" lvl="1">
               <a:lnSpc>
-                <a:spcPts val="5821"/>
+                <a:spcPts val="6236"/>
               </a:lnSpc>
               <a:buFont typeface="Arial"/>
               <a:buChar char="•"/>
             </a:pPr>
             <a:r>
-              <a:rPr lang="en-US" sz="3684">
+              <a:rPr lang="en-US" sz="3947">
                 <a:solidFill>
                   <a:srgbClr val="000000"/>
                 </a:solidFill>
@@ -24025,19 +24058,19 @@
                 <a:cs typeface="Open Sans Extra Bold"/>
                 <a:sym typeface="Open Sans Extra Bold"/>
               </a:rPr>
-              <a:t>Rails decide o óbvio por você. Siga a convenção.</a:t>
+              <a:t>git push: manda para o GitHub</a:t>
             </a:r>
           </a:p>
           <a:p>
             <a:pPr algn="l" marL="1136378" indent="-568189" lvl="1">
               <a:lnSpc>
-                <a:spcPts val="5821"/>
+                <a:spcPts val="6236"/>
               </a:lnSpc>
               <a:buFont typeface="Arial"/>
               <a:buChar char="•"/>
             </a:pPr>
             <a:r>
-              <a:rPr lang="en-US" sz="3684">
+              <a:rPr lang="en-US" sz="3947">
                 <a:solidFill>
                   <a:srgbClr val="000000"/>
                 </a:solidFill>
@@ -24046,7 +24079,7 @@
                 <a:cs typeface="Open Sans Extra Bold"/>
                 <a:sym typeface="Open Sans Extra Bold"/>
               </a:rPr>
-              <a:t>Você já tem uma API respondendo. Na próxima ela ganha banco.</a:t>
+              <a:t>Na Aula 4, é o push que dispara o deploy. Literalmente.</a:t>
             </a:r>
           </a:p>
         </p:txBody>
@@ -24106,6 +24139,284 @@
 </file>
 
 <file path=ppt/slides/slide64.xml><?xml version="1.0" encoding="utf-8"?>
+<p:sld xmlns:a="http://schemas.openxmlformats.org/drawingml/2006/main" xmlns:p="http://schemas.openxmlformats.org/presentationml/2006/main" xmlns:r="http://schemas.openxmlformats.org/officeDocument/2006/relationships">
+  <p:cSld>
+    <p:spTree>
+      <p:nvGrpSpPr>
+        <p:cNvPr id="1" name=""/>
+        <p:cNvGrpSpPr/>
+        <p:nvPr/>
+      </p:nvGrpSpPr>
+      <p:grpSpPr/>
+      <p:sp>
+        <p:nvSpPr>
+          <p:cNvPr name="Freeform 2" id="2"/>
+          <p:cNvSpPr/>
+          <p:nvPr/>
+        </p:nvSpPr>
+        <p:spPr>
+          <a:xfrm flipH="false" flipV="false" rot="0">
+            <a:off x="0" y="0"/>
+            <a:ext cx="18288000" cy="10287000"/>
+          </a:xfrm>
+          <a:custGeom>
+            <a:avLst/>
+            <a:gdLst/>
+            <a:ahLst/>
+            <a:cxnLst/>
+            <a:rect r="r" b="b" t="t" l="l"/>
+            <a:pathLst>
+              <a:path h="10287000" w="18288000">
+                <a:moveTo>
+                  <a:pt x="0" y="0"/>
+                </a:moveTo>
+                <a:lnTo>
+                  <a:pt x="18288000" y="0"/>
+                </a:lnTo>
+                <a:lnTo>
+                  <a:pt x="18288000" y="10287000"/>
+                </a:lnTo>
+                <a:lnTo>
+                  <a:pt x="0" y="10287000"/>
+                </a:lnTo>
+                <a:lnTo>
+                  <a:pt x="0" y="0"/>
+                </a:lnTo>
+                <a:close/>
+              </a:path>
+            </a:pathLst>
+          </a:custGeom>
+          <a:blipFill>
+            <a:blip r:embed="rId2"/>
+            <a:stretch>
+              <a:fillRect l="0" t="-38888" r="0" b="-38888"/>
+            </a:stretch>
+          </a:blipFill>
+        </p:spPr>
+      </p:sp>
+      <p:sp>
+        <p:nvSpPr>
+          <p:cNvPr name="TextBox 3" id="3"/>
+          <p:cNvSpPr txBox="true"/>
+          <p:nvPr/>
+        </p:nvSpPr>
+        <p:spPr>
+          <a:xfrm rot="0">
+            <a:off x="914400" y="1271761"/>
+            <a:ext cx="16459200" cy="912875"/>
+          </a:xfrm>
+          <a:prstGeom prst="rect">
+            <a:avLst/>
+          </a:prstGeom>
+        </p:spPr>
+        <p:txBody>
+          <a:bodyPr anchor="t" rtlCol="false" tIns="0" lIns="0" bIns="0" rIns="0">
+            <a:spAutoFit/>
+          </a:bodyPr>
+          <a:lstStyle/>
+          <a:p>
+            <a:pPr algn="ctr">
+              <a:lnSpc>
+                <a:spcPts val="5939"/>
+              </a:lnSpc>
+            </a:pPr>
+            <a:r>
+              <a:rPr lang="en-US" sz="4242">
+                <a:solidFill>
+                  <a:srgbClr val="FF751F"/>
+                </a:solidFill>
+                <a:latin typeface="Open Sans Extra Bold"/>
+                <a:ea typeface="Open Sans Extra Bold"/>
+                <a:cs typeface="Open Sans Extra Bold"/>
+                <a:sym typeface="Open Sans Extra Bold"/>
+              </a:rPr>
+              <a:t>RECAPITULANDO</a:t>
+            </a:r>
+          </a:p>
+        </p:txBody>
+      </p:sp>
+      <p:sp>
+        <p:nvSpPr>
+          <p:cNvPr name="TextBox 4" id="4"/>
+          <p:cNvSpPr txBox="true"/>
+          <p:nvPr/>
+        </p:nvSpPr>
+        <p:spPr>
+          <a:xfrm rot="0">
+            <a:off x="1028700" y="3112207"/>
+            <a:ext cx="15503549" cy="4127486"/>
+          </a:xfrm>
+          <a:prstGeom prst="rect">
+            <a:avLst/>
+          </a:prstGeom>
+        </p:spPr>
+        <p:txBody>
+          <a:bodyPr anchor="t" rtlCol="false" tIns="0" lIns="0" bIns="0" rIns="0">
+            <a:spAutoFit/>
+          </a:bodyPr>
+          <a:lstStyle/>
+          <a:p>
+            <a:pPr algn="l" marL="1136378" indent="-568189" lvl="1">
+              <a:lnSpc>
+                <a:spcPts val="5821"/>
+              </a:lnSpc>
+              <a:buFont typeface="Arial"/>
+              <a:buChar char="•"/>
+            </a:pPr>
+            <a:r>
+              <a:rPr lang="en-US" sz="3684">
+                <a:solidFill>
+                  <a:srgbClr val="000000"/>
+                </a:solidFill>
+                <a:latin typeface="Open Sans Extra Bold"/>
+                <a:ea typeface="Open Sans Extra Bold"/>
+                <a:cs typeface="Open Sans Extra Bold"/>
+                <a:sym typeface="Open Sans Extra Bold"/>
+              </a:rPr>
+              <a:t>Back-end é a cozinha: regra, dado e permissão.</a:t>
+            </a:r>
+          </a:p>
+          <a:p>
+            <a:pPr algn="l" marL="1136378" indent="-568189" lvl="1">
+              <a:lnSpc>
+                <a:spcPts val="5821"/>
+              </a:lnSpc>
+              <a:buFont typeface="Arial"/>
+              <a:buChar char="•"/>
+            </a:pPr>
+            <a:r>
+              <a:rPr lang="en-US" sz="3684">
+                <a:solidFill>
+                  <a:srgbClr val="000000"/>
+                </a:solidFill>
+                <a:latin typeface="Open Sans Extra Bold"/>
+                <a:ea typeface="Open Sans Extra Bold"/>
+                <a:cs typeface="Open Sans Extra Bold"/>
+                <a:sym typeface="Open Sans Extra Bold"/>
+              </a:rPr>
+              <a:t>HTTP é o idioma; verbo, status e JSON são o vocabulário.</a:t>
+            </a:r>
+          </a:p>
+          <a:p>
+            <a:pPr algn="l" marL="1136378" indent="-568189" lvl="1">
+              <a:lnSpc>
+                <a:spcPts val="5821"/>
+              </a:lnSpc>
+              <a:buFont typeface="Arial"/>
+              <a:buChar char="•"/>
+            </a:pPr>
+            <a:r>
+              <a:rPr lang="en-US" sz="3684">
+                <a:solidFill>
+                  <a:srgbClr val="000000"/>
+                </a:solidFill>
+                <a:latin typeface="Open Sans Extra Bold"/>
+                <a:ea typeface="Open Sans Extra Bold"/>
+                <a:cs typeface="Open Sans Extra Bold"/>
+                <a:sym typeface="Open Sans Extra Bold"/>
+              </a:rPr>
+              <a:t>Ruby é Python com outra sintaxe e mais açúcar.</a:t>
+            </a:r>
+          </a:p>
+          <a:p>
+            <a:pPr algn="l" marL="1136378" indent="-568189" lvl="1">
+              <a:lnSpc>
+                <a:spcPts val="5821"/>
+              </a:lnSpc>
+              <a:buFont typeface="Arial"/>
+              <a:buChar char="•"/>
+            </a:pPr>
+            <a:r>
+              <a:rPr lang="en-US" sz="3684">
+                <a:solidFill>
+                  <a:srgbClr val="000000"/>
+                </a:solidFill>
+                <a:latin typeface="Open Sans Extra Bold"/>
+                <a:ea typeface="Open Sans Extra Bold"/>
+                <a:cs typeface="Open Sans Extra Bold"/>
+                <a:sym typeface="Open Sans Extra Bold"/>
+              </a:rPr>
+              <a:t>Rails decide o óbvio por você. Siga a convenção.</a:t>
+            </a:r>
+          </a:p>
+          <a:p>
+            <a:pPr algn="l" marL="1136378" indent="-568189" lvl="1">
+              <a:lnSpc>
+                <a:spcPts val="5821"/>
+              </a:lnSpc>
+              <a:buFont typeface="Arial"/>
+              <a:buChar char="•"/>
+            </a:pPr>
+            <a:r>
+              <a:rPr lang="en-US" sz="3684">
+                <a:solidFill>
+                  <a:srgbClr val="000000"/>
+                </a:solidFill>
+                <a:latin typeface="Open Sans Extra Bold"/>
+                <a:ea typeface="Open Sans Extra Bold"/>
+                <a:cs typeface="Open Sans Extra Bold"/>
+                <a:sym typeface="Open Sans Extra Bold"/>
+              </a:rPr>
+              <a:t>Você já tem uma API respondendo. Na próxima ela ganha banco.</a:t>
+            </a:r>
+          </a:p>
+        </p:txBody>
+      </p:sp>
+      <p:sp>
+        <p:nvSpPr>
+          <p:cNvPr name="Freeform 5" id="5"/>
+          <p:cNvSpPr/>
+          <p:nvPr/>
+        </p:nvSpPr>
+        <p:spPr>
+          <a:xfrm flipH="false" flipV="false" rot="0">
+            <a:off x="16096853" y="282073"/>
+            <a:ext cx="1788433" cy="1493254"/>
+          </a:xfrm>
+          <a:custGeom>
+            <a:avLst/>
+            <a:gdLst/>
+            <a:ahLst/>
+            <a:cxnLst/>
+            <a:rect r="r" b="b" t="t" l="l"/>
+            <a:pathLst>
+              <a:path h="1493254" w="1788433">
+                <a:moveTo>
+                  <a:pt x="0" y="0"/>
+                </a:moveTo>
+                <a:lnTo>
+                  <a:pt x="1788433" y="0"/>
+                </a:lnTo>
+                <a:lnTo>
+                  <a:pt x="1788433" y="1493254"/>
+                </a:lnTo>
+                <a:lnTo>
+                  <a:pt x="0" y="1493254"/>
+                </a:lnTo>
+                <a:lnTo>
+                  <a:pt x="0" y="0"/>
+                </a:lnTo>
+                <a:close/>
+              </a:path>
+            </a:pathLst>
+          </a:custGeom>
+          <a:blipFill>
+            <a:blip r:embed="rId3"/>
+            <a:stretch>
+              <a:fillRect l="0" t="0" r="0" b="0"/>
+            </a:stretch>
+          </a:blipFill>
+        </p:spPr>
+      </p:sp>
+    </p:spTree>
+  </p:cSld>
+  <p:clrMapOvr>
+    <a:masterClrMapping/>
+  </p:clrMapOvr>
+</p:sld>
+</file>
+
+<file path=ppt/slides/slide65.xml><?xml version="1.0" encoding="utf-8"?>
 <p:sld xmlns:a="http://schemas.openxmlformats.org/drawingml/2006/main" xmlns:p="http://schemas.openxmlformats.org/presentationml/2006/main" xmlns:r="http://schemas.openxmlformats.org/officeDocument/2006/relationships">
   <p:cSld>
     <p:spTree>

</xml_diff>